<commit_message>
Final project files for evaluation
</commit_message>
<xml_diff>
--- a/cricbuzz/Cricbuzz_final/CricBuzz.pptx
+++ b/cricbuzz/Cricbuzz_final/CricBuzz.pptx
@@ -7818,7 +7818,7 @@
           <a:p>
             <a:fld id="{41CC4456-0E88-4EB2-8FDA-8240F984B54A}" type="datetimeFigureOut">
               <a:rPr lang="en-US" smtClean="0"/>
-              <a:t>3/14/2026</a:t>
+              <a:t>3/15/2026</a:t>
             </a:fld>
             <a:endParaRPr lang="en-US" dirty="0"/>
           </a:p>
@@ -7995,7 +7995,7 @@
           <a:p>
             <a:fld id="{AE5E9994-CBF9-4364-B2D1-761774B9F53C}" type="datetimeFigureOut">
               <a:rPr lang="en-US" smtClean="0"/>
-              <a:t>3/14/2026</a:t>
+              <a:t>3/15/2026</a:t>
             </a:fld>
             <a:endParaRPr lang="en-US" dirty="0"/>
           </a:p>
@@ -22811,34 +22811,20 @@
               <a:buChar char="•"/>
             </a:pPr>
             <a:r>
-              <a:rPr lang="en-US" b="1">
+              <a:rPr lang="en-US" b="1" dirty="0">
                 <a:ea typeface="+mn-lt"/>
                 <a:cs typeface="+mn-lt"/>
               </a:rPr>
               <a:t>Multi-Format Analysis</a:t>
             </a:r>
             <a:r>
-              <a:rPr lang="en-US">
+              <a:rPr lang="en-US" dirty="0">
                 <a:ea typeface="+mn-lt"/>
                 <a:cs typeface="+mn-lt"/>
               </a:rPr>
-              <a:t>: Features interactive toggles to switch between </a:t>
-            </a:r>
-            <a:r>
-              <a:rPr lang="en-US" b="1">
-                <a:ea typeface="+mn-lt"/>
-                <a:cs typeface="+mn-lt"/>
-              </a:rPr>
-              <a:t>Test, ODI, and T20I</a:t>
-            </a:r>
-            <a:r>
-              <a:rPr lang="en-US">
-                <a:ea typeface="+mn-lt"/>
-                <a:cs typeface="+mn-lt"/>
-              </a:rPr>
-              <a:t> data for comprehensive performance reviews.</a:t>
-            </a:r>
-            <a:endParaRPr lang="en-US"/>
+              <a:t>: Features interactive toggles to switch between personal info, batting and bowling data for comprehensive performance reviews.</a:t>
+            </a:r>
+            <a:endParaRPr lang="en-US" dirty="0"/>
           </a:p>
           <a:p>
             <a:pPr marL="285750" indent="-285750">
@@ -22846,20 +22832,20 @@
               <a:buChar char="•"/>
             </a:pPr>
             <a:r>
-              <a:rPr lang="en-US" b="1">
+              <a:rPr lang="en-US" b="1" dirty="0">
                 <a:ea typeface="+mn-lt"/>
                 <a:cs typeface="+mn-lt"/>
               </a:rPr>
               <a:t>Real-Time Interactivity</a:t>
             </a:r>
             <a:r>
-              <a:rPr lang="en-US">
+              <a:rPr lang="en-US" dirty="0">
                 <a:ea typeface="+mn-lt"/>
                 <a:cs typeface="+mn-lt"/>
               </a:rPr>
               <a:t>: Enables instant sorting and searching of player metrics, such as batting averages and strike rates, without page reloads.</a:t>
             </a:r>
-            <a:endParaRPr lang="en-US"/>
+            <a:endParaRPr lang="en-US" dirty="0"/>
           </a:p>
           <a:p>
             <a:pPr marL="285750" indent="-285750">
@@ -22881,7 +22867,7 @@
               <a:t>: Acts as the primary interface for capturing live stats before they are committed to the </a:t>
             </a:r>
             <a:r>
-              <a:rPr lang="en-US" b="1" dirty="0" err="1">
+              <a:rPr lang="en-US" dirty="0" err="1">
                 <a:latin typeface="Consolas"/>
               </a:rPr>
               <a:t>cricbuzz</a:t>
@@ -22891,21 +22877,7 @@
                 <a:ea typeface="+mn-lt"/>
                 <a:cs typeface="+mn-lt"/>
               </a:rPr>
-              <a:t> database on the </a:t>
-            </a:r>
-            <a:r>
-              <a:rPr lang="en-US" b="1" dirty="0">
-                <a:ea typeface="+mn-lt"/>
-                <a:cs typeface="+mn-lt"/>
-              </a:rPr>
-              <a:t>Deeps</a:t>
-            </a:r>
-            <a:r>
-              <a:rPr lang="en-US" dirty="0">
-                <a:ea typeface="+mn-lt"/>
-                <a:cs typeface="+mn-lt"/>
-              </a:rPr>
-              <a:t> server.</a:t>
+              <a:t> database on the Deeps server.</a:t>
             </a:r>
             <a:endParaRPr lang="en-US" dirty="0"/>
           </a:p>
@@ -22939,17 +22911,6 @@
 <file path=ppt/slides/slide19.xml><?xml version="1.0" encoding="utf-8"?>
 <p:sld xmlns:a="http://schemas.openxmlformats.org/drawingml/2006/main" xmlns:r="http://schemas.openxmlformats.org/officeDocument/2006/relationships" xmlns:p="http://schemas.openxmlformats.org/presentationml/2006/main">
   <p:cSld>
-    <p:bg>
-      <p:bgPr>
-        <a:blipFill>
-          <a:blip r:embed="rId2"/>
-          <a:stretch>
-            <a:fillRect/>
-          </a:stretch>
-        </a:blipFill>
-        <a:effectLst/>
-      </p:bgPr>
-    </p:bg>
     <p:spTree>
       <p:nvGrpSpPr>
         <p:cNvPr id="1" name=""/>
@@ -23022,6 +22983,36 @@
           </a:p>
         </p:txBody>
       </p:sp>
+      <p:pic>
+        <p:nvPicPr>
+          <p:cNvPr id="5" name="Picture 4">
+            <a:extLst>
+              <a:ext uri="{FF2B5EF4-FFF2-40B4-BE49-F238E27FC236}">
+                <a16:creationId xmlns:a16="http://schemas.microsoft.com/office/drawing/2014/main" id="{C2EF5763-8783-DA47-9279-0FF8CF58A05D}"/>
+              </a:ext>
+            </a:extLst>
+          </p:cNvPr>
+          <p:cNvPicPr>
+            <a:picLocks noChangeAspect="1"/>
+          </p:cNvPicPr>
+          <p:nvPr/>
+        </p:nvPicPr>
+        <p:blipFill>
+          <a:blip r:embed="rId2"/>
+          <a:stretch>
+            <a:fillRect/>
+          </a:stretch>
+        </p:blipFill>
+        <p:spPr>
+          <a:xfrm>
+            <a:off x="0" y="1673"/>
+            <a:ext cx="12192000" cy="6854653"/>
+          </a:xfrm>
+          <a:prstGeom prst="rect">
+            <a:avLst/>
+          </a:prstGeom>
+        </p:spPr>
+      </p:pic>
     </p:spTree>
     <p:extLst>
       <p:ext uri="{BB962C8B-B14F-4D97-AF65-F5344CB8AC3E}">
@@ -23339,17 +23330,6 @@
 <file path=ppt/slides/slide20.xml><?xml version="1.0" encoding="utf-8"?>
 <p:sld xmlns:a="http://schemas.openxmlformats.org/drawingml/2006/main" xmlns:r="http://schemas.openxmlformats.org/officeDocument/2006/relationships" xmlns:p="http://schemas.openxmlformats.org/presentationml/2006/main">
   <p:cSld>
-    <p:bg>
-      <p:bgPr>
-        <a:blipFill>
-          <a:blip r:embed="rId2"/>
-          <a:stretch>
-            <a:fillRect/>
-          </a:stretch>
-        </a:blipFill>
-        <a:effectLst/>
-      </p:bgPr>
-    </p:bg>
     <p:spTree>
       <p:nvGrpSpPr>
         <p:cNvPr id="1" name="">
@@ -23428,6 +23408,36 @@
           </a:p>
         </p:txBody>
       </p:sp>
+      <p:pic>
+        <p:nvPicPr>
+          <p:cNvPr id="5" name="Picture 4">
+            <a:extLst>
+              <a:ext uri="{FF2B5EF4-FFF2-40B4-BE49-F238E27FC236}">
+                <a16:creationId xmlns:a16="http://schemas.microsoft.com/office/drawing/2014/main" id="{2AFA8E52-E00F-6CA1-DF97-6894854209FD}"/>
+              </a:ext>
+            </a:extLst>
+          </p:cNvPr>
+          <p:cNvPicPr>
+            <a:picLocks noChangeAspect="1"/>
+          </p:cNvPicPr>
+          <p:nvPr/>
+        </p:nvPicPr>
+        <p:blipFill>
+          <a:blip r:embed="rId2"/>
+          <a:stretch>
+            <a:fillRect/>
+          </a:stretch>
+        </p:blipFill>
+        <p:spPr>
+          <a:xfrm>
+            <a:off x="0" y="1673"/>
+            <a:ext cx="12192000" cy="6854653"/>
+          </a:xfrm>
+          <a:prstGeom prst="rect">
+            <a:avLst/>
+          </a:prstGeom>
+        </p:spPr>
+      </p:pic>
     </p:spTree>
     <p:extLst>
       <p:ext uri="{BB962C8B-B14F-4D97-AF65-F5344CB8AC3E}">
@@ -27824,35 +27834,6 @@
 </file>
 
 <file path=customXml/item1.xml><?xml version="1.0" encoding="utf-8"?>
-<p:properties xmlns:p="http://schemas.microsoft.com/office/2006/metadata/properties" xmlns:xsi="http://www.w3.org/2001/XMLSchema-instance" xmlns:pc="http://schemas.microsoft.com/office/infopath/2007/PartnerControls">
-  <documentManagement>
-    <_ip_UnifiedCompliancePolicyUIAction xmlns="http://schemas.microsoft.com/sharepoint/v3" xsi:nil="true"/>
-    <Image xmlns="71af3243-3dd4-4a8d-8c0d-dd76da1f02a5">
-      <Url xsi:nil="true"/>
-      <Description xsi:nil="true"/>
-    </Image>
-    <Status xmlns="71af3243-3dd4-4a8d-8c0d-dd76da1f02a5">Not started</Status>
-    <Background xmlns="71af3243-3dd4-4a8d-8c0d-dd76da1f02a5">false</Background>
-    <_ip_UnifiedCompliancePolicyProperties xmlns="http://schemas.microsoft.com/sharepoint/v3" xsi:nil="true"/>
-    <ImageTagsTaxHTField xmlns="71af3243-3dd4-4a8d-8c0d-dd76da1f02a5">
-      <Terms xmlns="http://schemas.microsoft.com/office/infopath/2007/PartnerControls"/>
-    </ImageTagsTaxHTField>
-    <TaxCatchAll xmlns="230e9df3-be65-4c73-a93b-d1236ebd677e" xsi:nil="true"/>
-    <MediaServiceKeyPoints xmlns="71af3243-3dd4-4a8d-8c0d-dd76da1f02a5" xsi:nil="true"/>
-  </documentManagement>
-</p:properties>
-</file>
-
-<file path=customXml/item2.xml><?xml version="1.0" encoding="utf-8"?>
-<?mso-contentType ?>
-<FormTemplates xmlns="http://schemas.microsoft.com/sharepoint/v3/contenttype/forms">
-  <Display>DocumentLibraryForm</Display>
-  <Edit>DocumentLibraryForm</Edit>
-  <New>DocumentLibraryForm</New>
-</FormTemplates>
-</file>
-
-<file path=customXml/item3.xml><?xml version="1.0" encoding="utf-8"?>
 <ct:contentTypeSchema xmlns:ct="http://schemas.microsoft.com/office/2006/metadata/contentType" xmlns:ma="http://schemas.microsoft.com/office/2006/metadata/properties/metaAttributes" ct:_="" ma:_="" ma:contentTypeName="Document" ma:contentTypeID="0x01010079F111ED35F8CC479449609E8A0923A6" ma:contentTypeVersion="28" ma:contentTypeDescription="Create a new document." ma:contentTypeScope="" ma:versionID="60f5a4f2d2b0abadcf532d48ebf9cb71">
   <xsd:schema xmlns:xsd="http://www.w3.org/2001/XMLSchema" xmlns:xs="http://www.w3.org/2001/XMLSchema" xmlns:p="http://schemas.microsoft.com/office/2006/metadata/properties" xmlns:ns1="http://schemas.microsoft.com/sharepoint/v3" xmlns:ns2="71af3243-3dd4-4a8d-8c0d-dd76da1f02a5" xmlns:ns3="16c05727-aa75-4e4a-9b5f-8a80a1165891" xmlns:ns4="230e9df3-be65-4c73-a93b-d1236ebd677e" targetNamespace="http://schemas.microsoft.com/office/2006/metadata/properties" ma:root="true" ma:fieldsID="7dd78129e6a1811f84807ad11c651531" ns1:_="" ns2:_="" ns3:_="" ns4:_="">
     <xsd:import namespace="http://schemas.microsoft.com/sharepoint/v3"/>
@@ -28164,27 +28145,36 @@
 </ct:contentTypeSchema>
 </file>
 
-<file path=customXml/itemProps1.xml><?xml version="1.0" encoding="utf-8"?>
-<ds:datastoreItem xmlns:ds="http://schemas.openxmlformats.org/officeDocument/2006/customXml" ds:itemID="{27C9B6E4-47D3-464E-8364-AD7B35DA4B5C}">
-  <ds:schemaRefs>
-    <ds:schemaRef ds:uri="http://schemas.microsoft.com/office/2006/metadata/properties"/>
-    <ds:schemaRef ds:uri="http://schemas.microsoft.com/office/infopath/2007/PartnerControls"/>
-    <ds:schemaRef ds:uri="http://schemas.microsoft.com/sharepoint/v3"/>
-    <ds:schemaRef ds:uri="71af3243-3dd4-4a8d-8c0d-dd76da1f02a5"/>
-    <ds:schemaRef ds:uri="230e9df3-be65-4c73-a93b-d1236ebd677e"/>
-  </ds:schemaRefs>
-</ds:datastoreItem>
+<file path=customXml/item2.xml><?xml version="1.0" encoding="utf-8"?>
+<?mso-contentType ?>
+<FormTemplates xmlns="http://schemas.microsoft.com/sharepoint/v3/contenttype/forms">
+  <Display>DocumentLibraryForm</Display>
+  <Edit>DocumentLibraryForm</Edit>
+  <New>DocumentLibraryForm</New>
+</FormTemplates>
 </file>
 
-<file path=customXml/itemProps2.xml><?xml version="1.0" encoding="utf-8"?>
-<ds:datastoreItem xmlns:ds="http://schemas.openxmlformats.org/officeDocument/2006/customXml" ds:itemID="{2B0F9548-B8AC-4D42-9765-A5CD9A25F531}">
-  <ds:schemaRefs>
-    <ds:schemaRef ds:uri="http://schemas.microsoft.com/sharepoint/v3/contenttype/forms"/>
-  </ds:schemaRefs>
-</ds:datastoreItem>
+<file path=customXml/item3.xml><?xml version="1.0" encoding="utf-8"?>
+<p:properties xmlns:p="http://schemas.microsoft.com/office/2006/metadata/properties" xmlns:xsi="http://www.w3.org/2001/XMLSchema-instance" xmlns:pc="http://schemas.microsoft.com/office/infopath/2007/PartnerControls">
+  <documentManagement>
+    <_ip_UnifiedCompliancePolicyUIAction xmlns="http://schemas.microsoft.com/sharepoint/v3" xsi:nil="true"/>
+    <Image xmlns="71af3243-3dd4-4a8d-8c0d-dd76da1f02a5">
+      <Url xsi:nil="true"/>
+      <Description xsi:nil="true"/>
+    </Image>
+    <Status xmlns="71af3243-3dd4-4a8d-8c0d-dd76da1f02a5">Not started</Status>
+    <Background xmlns="71af3243-3dd4-4a8d-8c0d-dd76da1f02a5">false</Background>
+    <_ip_UnifiedCompliancePolicyProperties xmlns="http://schemas.microsoft.com/sharepoint/v3" xsi:nil="true"/>
+    <ImageTagsTaxHTField xmlns="71af3243-3dd4-4a8d-8c0d-dd76da1f02a5">
+      <Terms xmlns="http://schemas.microsoft.com/office/infopath/2007/PartnerControls"/>
+    </ImageTagsTaxHTField>
+    <TaxCatchAll xmlns="230e9df3-be65-4c73-a93b-d1236ebd677e" xsi:nil="true"/>
+    <MediaServiceKeyPoints xmlns="71af3243-3dd4-4a8d-8c0d-dd76da1f02a5" xsi:nil="true"/>
+  </documentManagement>
+</p:properties>
 </file>
 
-<file path=customXml/itemProps3.xml><?xml version="1.0" encoding="utf-8"?>
+<file path=customXml/itemProps1.xml><?xml version="1.0" encoding="utf-8"?>
 <ds:datastoreItem xmlns:ds="http://schemas.openxmlformats.org/officeDocument/2006/customXml" ds:itemID="{78C71B42-4016-428B-9745-27057802D00B}">
   <ds:schemaRefs>
     <ds:schemaRef ds:uri="http://schemas.microsoft.com/office/2006/metadata/contentType"/>
@@ -28205,6 +28195,26 @@
 </ds:datastoreItem>
 </file>
 
+<file path=customXml/itemProps2.xml><?xml version="1.0" encoding="utf-8"?>
+<ds:datastoreItem xmlns:ds="http://schemas.openxmlformats.org/officeDocument/2006/customXml" ds:itemID="{2B0F9548-B8AC-4D42-9765-A5CD9A25F531}">
+  <ds:schemaRefs>
+    <ds:schemaRef ds:uri="http://schemas.microsoft.com/sharepoint/v3/contenttype/forms"/>
+  </ds:schemaRefs>
+</ds:datastoreItem>
+</file>
+
+<file path=customXml/itemProps3.xml><?xml version="1.0" encoding="utf-8"?>
+<ds:datastoreItem xmlns:ds="http://schemas.openxmlformats.org/officeDocument/2006/customXml" ds:itemID="{27C9B6E4-47D3-464E-8364-AD7B35DA4B5C}">
+  <ds:schemaRefs>
+    <ds:schemaRef ds:uri="http://schemas.microsoft.com/office/2006/metadata/properties"/>
+    <ds:schemaRef ds:uri="http://schemas.microsoft.com/office/infopath/2007/PartnerControls"/>
+    <ds:schemaRef ds:uri="http://schemas.microsoft.com/sharepoint/v3"/>
+    <ds:schemaRef ds:uri="71af3243-3dd4-4a8d-8c0d-dd76da1f02a5"/>
+    <ds:schemaRef ds:uri="230e9df3-be65-4c73-a93b-d1236ebd677e"/>
+  </ds:schemaRefs>
+</ds:datastoreItem>
+</file>
+
 <file path=docMetadata/LabelInfo.xml><?xml version="1.0" encoding="utf-8"?>
 <clbl:labelList xmlns:clbl="http://schemas.microsoft.com/office/2020/mipLabelMetadata">
   <clbl:label id="{1a19d03a-48bc-4359-8038-5b5f6d5847c3}" enabled="1" method="Standard" siteId="{72f988bf-86f1-41af-91ab-2d7cd011db47}" removed="0"/>

</xml_diff>